<commit_message>
Pin verified references in Phase 1 deck and add PDF export
Point the demand-data reference at the IESO Hourly Zonal Demand
Report and give the full ICPC2T venue for Rawal and Ahmad. Add a PDF
copy of the deck for submission.

Co-Authored-By: Claude Opus 5.5 <noreply@anthropic.com>
Claude-Session: https://claude.ai/code/session_01UdtV5L4ADJ2YS9drm8okZJ
</commit_message>
<xml_diff>
--- a/presentation/ELG5255_Phase1_Ottawa_Load_Forecasting.pptx
+++ b/presentation/ELG5255_Phase1_Ottawa_Load_Forecasting.pptx
@@ -117,18 +117,18 @@
   <p:extLst>
     <p:ext uri="{521415D9-36F7-43E2-AB2F-B90AF26B5E84}">
       <p14:sectionLst xmlns:p14="http://schemas.microsoft.com/office/powerpoint/2010/main">
-        <p14:section name="Introduction" id="{fc5e6c51-75df-55ba-167f-addf18c2b59b}">
+        <p14:section name="Introduction" id="{6d1c36ce-2756-ece1-f911-bbfe7fa72514}">
           <p14:sldIdLst>
             <p14:sldId id="256"/>
             <p14:sldId id="257"/>
           </p14:sldIdLst>
         </p14:section>
-        <p14:section name="State of the art" id="{82237dc6-8d12-0764-a741-047812bb282d}">
+        <p14:section name="State of the art" id="{f74e6c5c-ef08-1fe5-2bed-2f8604ff4bd5}">
           <p14:sldIdLst>
             <p14:sldId id="258"/>
           </p14:sldIdLst>
         </p14:section>
-        <p14:section name="Proposal" id="{bbbaac68-4fb6-0c44-2f28-15aa3a0924f5}">
+        <p14:section name="Proposal" id="{e940063e-431e-3b0d-c3a6-b4b88f403c88}">
           <p14:sldIdLst>
             <p14:sldId id="259"/>
             <p14:sldId id="260"/>
@@ -136,7 +136,7 @@
             <p14:sldId id="262"/>
           </p14:sldIdLst>
         </p14:section>
-        <p14:section name="Plan" id="{916a98c7-461d-dfb8-65f3-b9a1b0870e53}">
+        <p14:section name="Plan" id="{e1397f3b-0035-456c-f44d-f52edfebda30}">
           <p14:sldIdLst>
             <p14:sldId id="263"/>
             <p14:sldId id="264"/>
@@ -2614,7 +2614,7 @@
                   <a:schemeClr val="tx1"/>
                 </a:solidFill>
               </a:rPr>
-              <a:t>[2] Rawal and Ahmad, “A Comparative Analysis of Supervised Machine Learning Algorithms for Electricity Demand Forecasting,” in Proc. IEEE ICPC2T, 2022. doi: 10.1109/ICPC2T53885.2022.9776960.</a:t>
+              <a:t>[2] Rawal and Ahmad, “A Comparative Analysis of Supervised Machine Learning Algorithms for Electricity Demand Forecasting,” in Proc. 2nd Int. Conf. Power, Control and Computing Technologies (ICPC2T), 2022, pp. 1–6. doi: 10.1109/ICPC2T53885.2022.9776960.</a:t>
             </a:r>
             <a:endParaRPr lang="en-US" sz="1200" dirty="0"/>
           </a:p>
@@ -2648,7 +2648,7 @@
                   <a:schemeClr val="tx1"/>
                 </a:solidFill>
               </a:rPr>
-              <a:t>[4] Independent Electricity System Operator (IESO), “Hourly Zonal Demand Report” and “Ontario Demand Reports.” [Online]. Available: https://reports-public.ieso.ca/public/</a:t>
+              <a:t>[4] Independent Electricity System Operator (IESO), “Hourly Zonal Demand Report.” [Online]. Available: https://reports-public.ieso.ca/public/DemandZonal/</a:t>
             </a:r>
             <a:endParaRPr lang="en-US" sz="1200" dirty="0"/>
           </a:p>
@@ -5492,7 +5492,7 @@
                             <a:srgbClr val="1B2A2F"/>
                           </a:solidFill>
                         </a:rPr>
-                        <a:t>IESO public reports: hourly zonal demand [4]</a:t>
+                        <a:t>IESO Hourly Zonal Demand Report, Ottawa zone [4]</a:t>
                       </a:r>
                       <a:endParaRPr lang="en-US" sz="1300" dirty="0"/>
                     </a:p>

</xml_diff>

<commit_message>
Proofread Phase 1 deck and expand study notes
Rewrite slide text in full, grammatical sentences and move speaker
notes into speaker_notes.js with a complete script, key facts and
likely questions for each slide. Expand STUDY_NOTES.md into a full
study guide covering grid background, model and metric explanations,
data sources, scenario formulas, paper deep dives, a 25-question Q&A
bank and a glossary, and regenerate the plain-text phone copy.

Co-Authored-By: Claude Opus 5.5 <noreply@anthropic.com>
Claude-Session: https://claude.ai/code/session_01UdtV5L4ADJ2YS9drm8okZJ
</commit_message>
<xml_diff>
--- a/presentation/ELG5255_Phase1_Ottawa_Load_Forecasting.pptx
+++ b/presentation/ELG5255_Phase1_Ottawa_Load_Forecasting.pptx
@@ -118,19 +118,19 @@
   <p:extLst>
     <p:ext uri="{521415D9-36F7-43E2-AB2F-B90AF26B5E84}">
       <p14:sectionLst xmlns:p14="http://schemas.microsoft.com/office/powerpoint/2010/main">
-        <p14:section name="Introduction" id="{aa4fc9f4-91ed-7e4a-2032-c221b61c09ba}">
+        <p14:section name="Introduction" id="{6a5dd4e8-011c-8696-00a3-a002bda99432}">
           <p14:sldIdLst>
             <p14:sldId id="256"/>
             <p14:sldId id="257"/>
           </p14:sldIdLst>
         </p14:section>
-        <p14:section name="State of the art" id="{074ce957-b07f-63b7-2cba-b1ad3c83fb20}">
+        <p14:section name="State of the art" id="{5df3b3a8-2b26-4e3e-2f0a-846d6c335ddf}">
           <p14:sldIdLst>
             <p14:sldId id="258"/>
             <p14:sldId id="259"/>
           </p14:sldIdLst>
         </p14:section>
-        <p14:section name="Proposal" id="{9fe16567-592c-b233-614e-69a4d5de6cc5}">
+        <p14:section name="Proposal" id="{b365a31b-9fc5-740b-13a6-cecdd1890216}">
           <p14:sldIdLst>
             <p14:sldId id="260"/>
             <p14:sldId id="261"/>
@@ -138,7 +138,7 @@
             <p14:sldId id="263"/>
           </p14:sldIdLst>
         </p14:section>
-        <p14:section name="Plan" id="{312bbaee-0342-c972-877b-84aaf05fafde}">
+        <p14:section name="Plan" id="{2c756542-2863-e649-ad44-8d26ddc7ae1a}">
           <p14:sldIdLst>
             <p14:sldId id="264"/>
             <p14:sldId id="265"/>
@@ -314,7 +314,7 @@
                 <c:ptCount val="6"/>
                 <c:lvl>
                   <c:pt idx="0">
-                    <c:v>Deep learning reg.</c:v>
+                    <c:v>Deep learning</c:v>
                   </c:pt>
                   <c:pt idx="1">
                     <c:v>LightGBM</c:v>
@@ -905,7 +905,13 @@
           <a:p>
             <a:r>
               <a:rPr lang="en-US" dirty="0"/>
-              <a:t>KSHITIJ (~10 s). Introduce the team and the one-line goal: forecast Ottawa's electricity load so the grid can plan supply ahead of demand.</a:t>
+              <a:t>PRESENTER: Kshitij · TIME: about 10 seconds
+SCRIPT
+"Hello, I'm Kshitij, and this is Victor. Our project forecasts Ottawa's electricity load with machine learning, so that the grid can plan its supply ahead of demand instead of reacting to it."
+KEY FACTS
+- Course: ELG 5255 Applied Machine Learning, Phase 1 proposal (8% of the final grade).
+- Topic area from the course brief: smart grid, load forecasting for residential areas.
+- The whole talk must fit in 5 minutes; Q&amp;A follows.</a:t>
             </a:r>
             <a:endParaRPr lang="en-US" dirty="0"/>
           </a:p>
@@ -993,7 +999,12 @@
           <a:p>
             <a:r>
               <a:rPr lang="en-US" dirty="0"/>
-              <a:t>Either presenter (~15 s). Who did what, and how AI tools were used. Make sure this matches what you actually did before presenting.</a:t>
+              <a:t>PRESENTER: either · TIME: about 15 seconds
+SCRIPT
+"Kshitij led the problem definition, the smart-grid scenario layer and the plan. Victor led the literature review, the data pipeline and the evaluation design. We will share the coding and the report. We used ChatGPT for summary tables and diagrams in our draft, and Claude to restructure and proofread the slides and check citations. We chose the problem, papers and methods ourselves, and we checked every number against the papers."
+KEY FACTS
+- The course requires every deliverable to state each member's contribution, signed by all members.
+- Check that the contribution lines are accurate before presenting.</a:t>
             </a:r>
             <a:endParaRPr lang="en-US" dirty="0"/>
           </a:p>
@@ -1081,7 +1092,9 @@
           <a:p>
             <a:r>
               <a:rPr lang="en-US" dirty="0"/>
-              <a:t/>
+              <a:t>Do not read this slide aloud. Leave it up only if asked about a source.
+- [1]–[4] are the literature review; [1], [2] and [4] are IEEE, [3] is MDPI Energies (open access).
+- [5]–[7] are data sources; [8] is the solar model library; [9] and [10] are the original Random Forest and XGBoost papers.</a:t>
             </a:r>
             <a:endParaRPr lang="en-US" dirty="0"/>
           </a:p>
@@ -1169,7 +1182,13 @@
           <a:p>
             <a:r>
               <a:rPr lang="en-US" dirty="0"/>
-              <a:t/>
+              <a:t>Q&amp;A (2 points of the rubric). Keep answers short and confident.
+- Why Ottawa? City scale is where local weather, holidays and EV fleets matter; IESO publishes Ottawa-zone hourly data.
+- Why not deep learning? In [3] it was only 0.3 points better in MAPE and took 20 min vs 7 s; LSTM is our stretch goal.
+- Which paper are you implementing? Gökçe &amp; Duman [1] (IEEE), extended to Ottawa with weekly lags, baseload and net load.
+- Are the solar, wind and EV numbers real? The weather inputs are real; the installations are hypothetical and labelled.
+- How do you avoid leakage? Chronological split; lags use only past values; scalers are fit on training data only.
+- Success criteria? All models beat persistence; RF and XGBoost beat LR on MAE, RMSE and MAPE in 2025.</a:t>
             </a:r>
             <a:endParaRPr lang="en-US" dirty="0"/>
           </a:p>
@@ -1257,7 +1276,18 @@
           <a:p>
             <a:r>
               <a:rPr lang="en-US" dirty="0"/>
-              <a:t>KSHITIJ (~35 s). Four drivers move Ottawa's load. Our question: do tree ensembles beat linear regression for hourly demand and next-day baseload? Define baseload as the daily minimum hourly load.</a:t>
+              <a:t>PRESENTER: Kshitij · TIME: about 35 seconds
+SCRIPT
+"Ottawa's electricity demand changes for four main reasons. First, weather: cold winters cause heating peaks and hot summers cause cooling peaks. Second, the calendar: workdays, weekends and statutory holidays each have a different daily load profile. Third, renewables: solar and wind output changes from hour to hour with the weather. And fourth, electrification: EV fleets add large charging loads, but those loads can be scheduled.
+So our research question is: can tree-ensemble models, Random Forest and XGBoost, forecast Ottawa's hourly demand and next-day baseload more accurately than a Linear Regression baseline, using past demand, weather and calendar features?
+By baseload we mean the minimum demand the grid must always serve. We define it as the lowest hourly load of each day."
+KEY FACTS
+- Two targets: (1) next-hour demand in MW; (2) next-day baseload = minimum hourly load of the next day.
+- Hourly load is U-shaped against temperature: it rises on cold days (heating) and on hot days (cooling).
+- 'Tree ensemble' = a model made of many decision trees whose predictions are combined.
+IF ASKED
+- Why baseload? It tells operators how much always-on generation (e.g., nuclear and hydro in Ontario) is needed, and when there may be surplus at night.
+- Why next-hour? It is the standard short-term load forecasting (STLF) horizon used in the papers we reviewed, so our results are comparable.</a:t>
             </a:r>
             <a:endParaRPr lang="en-US" dirty="0"/>
           </a:p>
@@ -1345,7 +1375,20 @@
           <a:p>
             <a:r>
               <a:rPr lang="en-US" dirty="0"/>
-              <a:t>VICTOR (~40 s). Four studies. Gökçe &amp; Duman (IEEE, Turkey): Random Forest and XGBoost beat Linear Regression; RMSE drops from 2348 to about 2040. Rawal &amp; Ahmad (IEEE, Australia): non-parametric models win, Random Forest best. Ibrahim et al. (Panama): deep regression is best at MAPE 2.9%, but Random Forest is almost as good (3.2%, R² 0.92) and trains in seconds instead of 20 minutes. Kong et al.: LSTMs shine at household level.</a:t>
+              <a:t>PRESENTER: Victor · TIME: about 40 seconds
+SCRIPT
+"We reviewed four recent studies. Gökçe and Duman, an IEEE conference paper from 2022, forecast Turkey's hourly demand with Linear Regression, Random Forest and XGBoost. Both tree models beat Linear Regression: RMSE dropped from about 2348 to 2075 for Random Forest and 2039 for XGBoost, and Random Forest had the lowest absolute and percentage errors.
+Rawal and Ahmad, also IEEE 2022, compared eight regression models on Australian data and found that non-parametric models outperformed parametric ones, with Random Forest the best.
+Ibrahim and colleagues, in Energies 2022, tested eight models on Panama's grid. The chart on the left shows their one-hour-ahead errors. Deep learning was best at 2.9 percent MAPE, but Random Forest was close behind at 3.2 percent, and it trained in 7 seconds instead of 20 minutes.
+Finally, Kong and colleagues, in IEEE Transactions on Smart Grid, showed that LSTM networks work well for individual households."
+KEY FACTS
+- [1] Gökçe &amp; Duman: Turkey, 1 Jan 2018 – 31 Dec 2021, 35,064 hourly records; features = month, weekday, hour, holiday flag, temperature of the 16 highest-consuming provinces, load 24 hours earlier; ~80/20 split. RMSE: LR 2348.35, RF 2075.32, XGBoost 2038.54. XGBoost best on squared error; RF best on absolute and percentage error. All models weaker in summer (COVID-19 recovery, extreme heat).
+- [2] Rawal &amp; Ahmad: New South Wales, 2020; eight models (linear, polynomial, SVR, elastic net, gradient boosting, decision tree, random forest, KNN). Non-parametric &gt; parametric; RF best. We have NOT verified their exact numbers, so do not quote any.
+- [3] Ibrahim et al.: Panama, Jan 2016 – Oct 2019, 33,600 hourly points; chronological 80/20 split. One-hour-ahead MAPE: deep learning 2.90%, LightGBM 3.07%, RF 3.22%, XGBoost 3.45%, SVR 4.90%, AdaBoost 5.70%. R²: deep learning 0.93, RF and LightGBM 0.92, XGBoost 0.91. 24-hour-ahead Bi-LSTM R² only 0.40, GRU 0.31.
+- [4] Kong et al.: LSTM on household smart-meter data; beats competing methods for individual homes.
+IF ASKED
+- 'Parametric' models assume a fixed formula with a fixed number of parameters (e.g., linear regression). 'Non-parametric' models, such as trees and KNN, let the data decide the shape of the function.
+- [3] is an MDPI journal, not IEEE. We use it for the review only; our implementation follows the IEEE paper [1].</a:t>
             </a:r>
             <a:endParaRPr lang="en-US" dirty="0"/>
           </a:p>
@@ -1433,7 +1476,17 @@
           <a:p>
             <a:r>
               <a:rPr lang="en-US" dirty="0"/>
-              <a:t>VICTOR (~35 s). Each lesson maps to a design choice on the right. Lags and temperature are the strongest predictors, so we use them. Holidays matter, so we flag Ontario holidays. Tree ensembles get within about a third of a percentage point of deep learning at a fraction of the cost, so they are our core models. And we will report errors by season and horizon, because that is where earlier models failed. The gap: nobody has done this for a single city zone with a renewables and EV net-load view.</a:t>
+              <a:t>PRESENTER: Victor · TIME: about 35 seconds
+SCRIPT
+"Here is how each lesson from the literature shapes our design. First, past load and temperature are the strongest predictors, so we use lags of one hour, one day and one week, together with temperature and humidity. Second, calendar effects matter, so we include Ontario's statutory holidays and a workday flag. Third, tree ensembles get within about a third of a percentage point of deep learning at a fraction of the cost, so Random Forest and XGBoost are our core models, with Linear Regression as the baseline. Fourth, earlier models struggled in extreme seasons and over longer horizons, so we will report errors by season and by horizon, and flag the 2020 COVID period.
+The gap we address: these studies forecast a whole country, a state or a single home. None looks at a city zone like Ottawa, or at how solar, wind and EV fleets change the net load the grid still has to serve."
+KEY FACTS
+- Lag notation: t-1 = one hour ago; t-24 = same hour yesterday; t-168 = same hour last week (7 × 24 = 168).
+- 0.3 percentage points: RF MAPE 3.22% vs deep learning 2.90% in [3].
+- Training cost in [3]: RF 7.1 s, LightGBM 0.8 s, XGBoost 3.3 s, deep learning about 1200 s (20 min).
+IF ASKED
+- Why humidity? [3] found it useful alongside temperature; humid summer days increase cooling load.
+- How do you flag COVID? A binary feature for the lockdown months of 2020, and an experiment training with and without 2020.</a:t>
             </a:r>
             <a:endParaRPr lang="en-US" dirty="0"/>
           </a:p>
@@ -1521,7 +1574,17 @@
           <a:p>
             <a:r>
               <a:rPr lang="en-US" dirty="0"/>
-              <a:t>KSHITIJ (~40 s). Steps 1-4 are the graded ML core, on real data. Step 5 is the smart-grid layer: we subtract assumed solar and wind farms and add EV fleet charging to get net load, the load that dispatchable supply must cover. This gives a dynamic load-distribution view without needing private utility data.</a:t>
+              <a:t>PRESENTER: Kshitij · TIME: about 40 seconds
+SCRIPT
+"Our solution has five steps. Steps one to four are the graded machine learning core, and they use only real data. We collect IESO's hourly demand for the Ottawa zone, weather from Environment Canada and Open-Meteo, and Ontario's holiday calendar. We engineer features: lags, temperature, heating and cooling degree-hours, and calendar variables. We train Linear Regression, Random Forest and XGBoost. And we forecast next-hour demand and next-day baseload.
+Step five is the smart-grid layer. We take the demand forecast, subtract the output of a solar farm and a wind farm, and add EV fleet charging. What is left is the net load: the load that controllable, or 'dispatchable', power plants must cover. This shows, hour by hour, how much supply is needed and when EV charging could be shifted to quieter hours."
+KEY FACTS
+- Net load = forecast demand − solar output − wind output + EV charging load.
+- Dispatchable supply = generation that operators can turn up or down on demand (e.g., hydro, gas), unlike solar and wind.
+- HDD/CDD (here degree-hours) = how far the temperature is below or above a base of about 18 °C; this captures heating and cooling demand.
+IF ASKED
+- Is step 5 machine learning? Not in itself: it is a physics- and rule-based simulation driven by our ML forecast. It turns the forecast into a smart-grid decision tool. The graded ML is in steps 1–4.
+- Is this real-time? No. We use historical data to show how the system would work; real-time control is out of scope.</a:t>
             </a:r>
             <a:endParaRPr lang="en-US" dirty="0"/>
           </a:p>
@@ -1609,7 +1672,18 @@
           <a:p>
             <a:r>
               <a:rPr lang="en-US" dirty="0"/>
-              <a:t>VICTOR (~30 s). Everything the ML model learns from is real public data: IESO zonal demand for Ottawa, ECCC and Open-Meteo weather, the holiday calendar. Only the scenario layer uses assumptions, and we label them. Chronological split avoids leakage.</a:t>
+              <a:t>PRESENTER: Victor · TIME: about 30 seconds
+SCRIPT
+"This table separates real data from assumptions. Everything the machine learning model learns from is real and public: IESO's hourly zonal demand for Ottawa, temperature and humidity from Environment and Climate Change Canada, solar irradiance and wind speed from Open-Meteo, and the Ontario holiday calendar. Only the scenario layer uses assumptions, and we label them clearly.
+We split the data chronologically: we train on 2020 to 2023, tune on 2024, and test on 2025. We never shuffle the data, so no information from the future can leak into training."
+KEY FACTS
+- IESO = Independent Electricity System Operator; it runs Ontario's grid and publishes the Hourly Zonal Demand Report for its 10 zones, one of which is Ottawa.
+- ECCC = Environment and Climate Change Canada (climate.weather.gc.ca), hourly station data.
+- Open-Meteo = free historical weather API with irradiance and 100 m wind speed.
+- Rows: about 6 years × 8,760 hours ≈ 52,600 hourly rows.
+IF ASKED
+- What is data leakage? When the model sees information during training that would not be available at prediction time, which makes test results look better than reality.
+- Missing values? Short gaps are interpolated; longer gaps are dropped and reported.</a:t>
             </a:r>
             <a:endParaRPr lang="en-US" dirty="0"/>
           </a:p>
@@ -1697,7 +1771,16 @@
           <a:p>
             <a:r>
               <a:rPr lang="en-US" dirty="0"/>
-              <a:t>KSHITIJ (~30 s). Where no public city-level data exists we make simple physical or calendar-based assumptions: a 10 MW solar farm via pvlib, a 20 MW wind farm via a standard power curve, residential load tied to temperature, industrial load tied to workdays, and a 300-vehicle EV fleet charging overnight. All are parameters, so we can run what-if scenarios.</a:t>
+              <a:t>PRESENTER: Kshitij · TIME: about 30 seconds
+SCRIPT
+"Where no public data exists at city level, we make simple, explicit assumptions. A 10-megawatt solar farm, modelled with the pvlib library from real irradiance. A 20-megawatt wind farm, using a standard turbine power curve on real wind speeds. Residential load that follows temperature, with morning and evening peaks. Industrial and commercial load that follows the working week. And a fleet of 300 electric vehicles charging overnight. We scale these shares to match IESO's real Ottawa total, and every number is a parameter, so we can run what-if scenarios."
+KEY FACTS
+- Wind power curve: no output below the cut-in speed (3 m/s); output rises roughly with the cube of wind speed up to the rated speed (12 m/s); full output up to the cut-out speed (25 m/s); shutdown above it for safety.
+- EV fleet energy: 300 vehicles × 60 kWh = 18 MWh per workday night; spread over 8 hours (22:00–06:00), that is about 2.25 MW on average.
+- pvlib = open-source Python library for modelling solar panel output from weather data [8].
+IF ASKED
+- Why these sizes? They are round, plausible numbers for a city-scale scenario, not real installations. The point is to show the method; any size can be swapped in.
+- Isn't this made up? The installations are hypothetical, but the weather that drives them is real, and we label them ASSUMED. The graded ML does not depend on them.</a:t>
             </a:r>
             <a:endParaRPr lang="en-US" dirty="0"/>
           </a:p>
@@ -1785,7 +1868,20 @@
           <a:p>
             <a:r>
               <a:rPr lang="en-US" dirty="0"/>
-              <a:t>VICTOR (~30 s). Four models from naive to XGBoost, all trained on the same features and split. Metrics: MAE, RMSE, MAPE and R² on the 2025 test year, broken down by season, peaks and holidays so we can analyse where each model fails.</a:t>
+              <a:t>PRESENTER: Victor · TIME: about 30 seconds
+SCRIPT
+"We compare four models trained on the same features and the same split. A persistence baseline, which simply says the next hour equals this hour; every model must beat it. Linear Regression, which is easy to interpret. Random Forest, an ensemble of decision trees that captures the U-shaped relationship between temperature and load. And XGBoost, which builds trees one after another, each correcting the errors of the previous ones.
+We evaluate on the unseen 2025 test year with four metrics: MAE, RMSE, MAPE and R-squared. And we analyse where each model fails: by season, at peak hours, and on holidays."
+KEY FACTS
+- MAE = average of |actual − predicted|, in MW. Easy to interpret.
+- RMSE = square root of the average squared error, in MW. Penalises large errors more.
+- MAPE = average of |error| / actual × 100%. Scale-free, so it can be compared across grids.
+- R² = 1 − (sum of squared errors / total variance). 1 is perfect; 0 means no better than predicting the mean.
+- Random Forest [9]: many trees, each trained on a bootstrap sample with random feature subsets; predictions are averaged (bagging), which reduces variance.
+- XGBoost [10]: gradient boosting; trees are added one at a time to fit the remaining errors, with regularisation to prevent overfitting.
+IF ASKED
+- Why both RMSE and MAE? In [1], the ranking of RF and XGBoost flipped depending on the metric, so we report both.
+- Hyperparameter tuning? Grid or random search on the 2024 validation year; [1] used GridSearchCV with 4-fold cross-validation.</a:t>
             </a:r>
             <a:endParaRPr lang="en-US" dirty="0"/>
           </a:p>
@@ -1873,7 +1969,15 @@
           <a:p>
             <a:r>
               <a:rPr lang="en-US" dirty="0"/>
-              <a:t>KSHITIJ (~25 s). Data is public and small enough for a laptop; the core ML does not depend on the scenarios, and we have a fallback to Ontario-wide data. Timeline runs to the Dec 8 presentation and Dec 14 report.</a:t>
+              <a:t>PRESENTER: Kshitij · TIME: about 25 seconds
+SCRIPT
+"This scope is realistic. The data is free, public and small: about 52,000 hourly rows, which trains in seconds to minutes on a laptop. We use standard libraries. The core deliverable does not depend on the scenario layer, so it cannot be put at risk by it. And if the Ottawa zonal data turns out incomplete, the same pipeline runs on Ontario-wide demand. Our timeline runs from data collection this month to the final presentation on December 8 and the report on December 14."
+KEY FACTS
+- Milestones: data and EDA by Oct 31; models trained by Nov 15; scenario layer by Nov 28; analysis and final presentation by Dec 8; IEEE-format report (at least 5 pages) by Dec 14.
+- Libraries: pandas (data), scikit-learn (LR, RF, metrics), xgboost, pvlib.
+IF ASKED
+- What if you fall behind? The scenario layer is the first thing to shrink; the ML core comes first.
+- What is EDA? Exploratory data analysis: plotting and summarising the data before modelling.</a:t>
             </a:r>
             <a:endParaRPr lang="en-US" dirty="0"/>
           </a:p>
@@ -2587,7 +2691,7 @@
                   <a:schemeClr val="bg2"/>
                 </a:solidFill>
               </a:rPr>
-              <a:t>Weather- and calendar-aware ML forecasts of hourly demand and baseload, with a net-load view of solar, wind and EV fleets</a:t>
+              <a:t>Weather- and calendar-aware machine learning forecasts of hourly demand and baseload, with a net-load view of solar, wind and EV fleets</a:t>
             </a:r>
             <a:endParaRPr lang="en-US" sz="1800" dirty="0"/>
           </a:p>
@@ -2988,7 +3092,7 @@
                   <a:schemeClr val="tx2"/>
                 </a:solidFill>
               </a:rPr>
-              <a:t>Both members will share coding and writing of the final report.</a:t>
+              <a:t>Both members will share the coding and the writing of the final report.</a:t>
             </a:r>
             <a:endParaRPr lang="en-US" sz="1300" dirty="0"/>
           </a:p>
@@ -3153,7 +3257,7 @@
                   <a:srgbClr val="FFFFFF"/>
                 </a:solidFill>
               </a:rPr>
-              <a:t>summary tables and illustrative diagrams in our draft.</a:t>
+              <a:t>creating summary tables and illustrative diagrams for our draft.</a:t>
             </a:r>
             <a:endParaRPr lang="en-US" sz="1400" dirty="0"/>
           </a:p>
@@ -3184,7 +3288,7 @@
                   <a:srgbClr val="FFFFFF"/>
                 </a:solidFill>
               </a:rPr>
-              <a:t>restructuring the deck for the 5-minute limit, slide wording and layout, checking citations, and drafting the scenario assumptions for us to review.</a:t>
+              <a:t>restructuring the deck for the 5-minute limit, improving slide wording and layout, proofreading, checking citations, and drafting the scenario assumptions for our review.</a:t>
             </a:r>
             <a:endParaRPr lang="en-US" sz="1400" dirty="0"/>
           </a:p>
@@ -3215,7 +3319,7 @@
                   <a:srgbClr val="FFFFFF"/>
                 </a:solidFill>
               </a:rPr>
-              <a:t>choice of problem, papers, data sources and methods. We checked every number against the cited papers and are responsible for all content.</a:t>
+              <a:t>the choice of problem, papers, data sources and methods. We checked every number against the cited papers and take responsibility for all content.</a:t>
             </a:r>
             <a:endParaRPr lang="en-US" sz="1400" dirty="0"/>
           </a:p>
@@ -3706,7 +3810,7 @@
                   <a:schemeClr val="accent1"/>
                 </a:solidFill>
               </a:rPr>
-              <a:t>Forecast Ottawa's load from real data · balance it against solar, wind and EV fleets</a:t>
+              <a:t>Forecasting Ottawa's load from real data and balancing it against solar, wind and EV fleets</a:t>
             </a:r>
             <a:endParaRPr lang="en-US" sz="1800" dirty="0"/>
           </a:p>
@@ -3769,7 +3873,7 @@
                   <a:schemeClr val="tx2"/>
                 </a:solidFill>
               </a:rPr>
-              <a:t>Problem: what drives Ottawa's electricity load</a:t>
+              <a:t>The problem: what drives Ottawa's electricity load?</a:t>
             </a:r>
             <a:endParaRPr lang="en-US" sz="3000" dirty="0"/>
           </a:p>
@@ -3904,7 +4008,7 @@
                   <a:schemeClr val="tx1"/>
                 </a:solidFill>
               </a:rPr>
-              <a:t>Cold winters drive heating peaks; hot summers drive cooling peaks</a:t>
+              <a:t>Cold winters cause heating peaks; hot summers cause cooling peaks</a:t>
             </a:r>
             <a:endParaRPr lang="en-US" sz="1800" dirty="0"/>
           </a:p>
@@ -4003,7 +4107,7 @@
                   <a:schemeClr val="tx1"/>
                 </a:solidFill>
               </a:rPr>
-              <a:t>Workdays, weekends and statutory holidays change the daily shape</a:t>
+              <a:t>Workdays, weekends and statutory holidays change the daily load profile</a:t>
             </a:r>
             <a:endParaRPr lang="en-US" sz="1800" dirty="0"/>
           </a:p>
@@ -4102,7 +4206,7 @@
                   <a:schemeClr val="tx1"/>
                 </a:solidFill>
               </a:rPr>
-              <a:t>Solar and wind output vary hour to hour with the forecast</a:t>
+              <a:t>Solar and wind output changes from hour to hour with the weather</a:t>
             </a:r>
             <a:endParaRPr lang="en-US" sz="1800" dirty="0"/>
           </a:p>
@@ -4201,7 +4305,7 @@
                   <a:schemeClr val="tx1"/>
                 </a:solidFill>
               </a:rPr>
-              <a:t>EV fleets add large, schedulable charging loads</a:t>
+              <a:t>EV fleets add large charging loads that can be scheduled</a:t>
             </a:r>
             <a:endParaRPr lang="en-US" sz="1800" dirty="0"/>
           </a:p>
@@ -4320,7 +4424,7 @@
                   <a:schemeClr val="bg2"/>
                 </a:solidFill>
               </a:rPr>
-              <a:t>Why it matters: a good forecast lets the grid schedule supply, storage and flexible loads (like EV charging) ahead of demand instead of reacting to it.</a:t>
+              <a:t>Why it matters: an accurate forecast lets the grid schedule supply, storage and flexible loads (such as EV charging) ahead of demand, instead of reacting to it.</a:t>
             </a:r>
             <a:endParaRPr lang="en-US" sz="2000" dirty="0"/>
           </a:p>
@@ -4356,7 +4460,7 @@
                   <a:schemeClr val="tx2"/>
                 </a:solidFill>
               </a:rPr>
-              <a:t>Baseload = the minimum level of demand the grid must always serve (we use the daily minimum hourly load).</a:t>
+              <a:t>Baseload is the minimum level of demand that the grid must always serve. We define it as the lowest hourly load of each day.</a:t>
             </a:r>
             <a:endParaRPr lang="en-US" sz="1200" dirty="0"/>
           </a:p>
@@ -4552,7 +4656,7 @@
                   <a:schemeClr val="tx2"/>
                 </a:solidFill>
               </a:rPr>
-              <a:t>Orange = the two models we propose. RF reaches R² 0.92 in 7.1 s of training vs 20 min for the deep model.</a:t>
+              <a:t>Orange bars mark the two models we propose. Random Forest reached R² = 0.92 with 7.1 s of training, versus 20 min for deep learning.</a:t>
             </a:r>
             <a:endParaRPr lang="en-US" sz="1100" dirty="0"/>
           </a:p>
@@ -4846,7 +4950,7 @@
                             <a:srgbClr val="1B2A2F"/>
                           </a:solidFill>
                         </a:rPr>
-                        <a:t>Turkey, hourly, 2018–21 (35,064 h); temperature, holidays, 24 h lag</a:t>
+                        <a:t>Turkey, hourly, 2018–21 (35,064 h); temperature, holidays, 24-hour lag</a:t>
                       </a:r>
                       <a:endParaRPr lang="en-US" sz="1100" dirty="0"/>
                     </a:p>
@@ -4907,7 +5011,7 @@
                             <a:srgbClr val="1B2A2F"/>
                           </a:solidFill>
                         </a:rPr>
-                        <a:t>RMSE: LR 2348 · RF 2075 · XGBoost 2039. RF best on absolute and % error</a:t>
+                        <a:t>RMSE: LR 2348, RF 2075, XGBoost 2039. RF had the lowest absolute and percentage errors</a:t>
                       </a:r>
                       <a:endParaRPr lang="en-US" sz="1100" dirty="0"/>
                     </a:p>
@@ -5031,7 +5135,7 @@
                             <a:srgbClr val="1B2A2F"/>
                           </a:solidFill>
                         </a:rPr>
-                        <a:t>New South Wales, Australia, 2020; 8 regression models</a:t>
+                        <a:t>New South Wales, Australia, 2020; eight regression models</a:t>
                       </a:r>
                       <a:endParaRPr lang="en-US" sz="1100" dirty="0"/>
                     </a:p>
@@ -5092,7 +5196,7 @@
                             <a:srgbClr val="1B2A2F"/>
                           </a:solidFill>
                         </a:rPr>
-                        <a:t>Non-parametric beat parametric models; Random Forest best</a:t>
+                        <a:t>Non-parametric models outperformed parametric ones; Random Forest was best</a:t>
                       </a:r>
                       <a:endParaRPr lang="en-US" sz="1100" dirty="0"/>
                     </a:p>
@@ -5216,7 +5320,7 @@
                             <a:srgbClr val="1B2A2F"/>
                           </a:solidFill>
                         </a:rPr>
-                        <a:t>Panama, hourly, 2016–19 (33,600 h); temperature, humidity, lags</a:t>
+                        <a:t>Panama, hourly, 2016–19 (33,600 h); temperature, humidity, lagged load</a:t>
                       </a:r>
                       <a:endParaRPr lang="en-US" sz="1100" dirty="0"/>
                     </a:p>
@@ -5277,7 +5381,7 @@
                             <a:srgbClr val="1B2A2F"/>
                           </a:solidFill>
                         </a:rPr>
-                        <a:t>Deep regression R² 0.93; RF and LightGBM R² 0.92; 24 h-ahead Bi-LSTM only 0.40</a:t>
+                        <a:t>Deep learning R² = 0.93; RF and LightGBM R² = 0.92; 24-hour-ahead Bi-LSTM only 0.40</a:t>
                       </a:r>
                       <a:endParaRPr lang="en-US" sz="1100" dirty="0"/>
                     </a:p>
@@ -5462,7 +5566,7 @@
                             <a:srgbClr val="1B2A2F"/>
                           </a:solidFill>
                         </a:rPr>
-                        <a:t>LSTM beats rival methods for individual homes</a:t>
+                        <a:t>LSTM outperformed competing methods for individual households</a:t>
                       </a:r>
                       <a:endParaRPr lang="en-US" sz="1100" dirty="0"/>
                     </a:p>
@@ -5616,7 +5720,7 @@
                   <a:schemeClr val="tx2"/>
                 </a:solidFill>
               </a:rPr>
-              <a:t>What the literature tells our design</a:t>
+              <a:t>How the literature shapes our design</a:t>
             </a:r>
             <a:endParaRPr lang="en-US" sz="3000" dirty="0"/>
           </a:p>
@@ -5764,7 +5868,7 @@
                   <a:srgbClr val="0F3B3F"/>
                 </a:solidFill>
               </a:rPr>
-              <a:t>Lagged load + temperature drive accuracy</a:t>
+              <a:t>Lagged load and temperature drive accuracy</a:t>
             </a:r>
             <a:endParaRPr lang="en-US" sz="1400" dirty="0"/>
           </a:p>
@@ -5778,7 +5882,7 @@
                   <a:srgbClr val="1B2A2F"/>
                 </a:solidFill>
               </a:rPr>
-              <a:t>Previous-week and previous-day load and temperature were the top predictors [3]; [1] used a 24 h lag.</a:t>
+              <a:t>Load from the previous week and day, plus temperature, were the top predictors in [3]; [1] used a 24-hour lag.</a:t>
             </a:r>
             <a:endParaRPr lang="en-US" sz="1400" dirty="0"/>
           </a:p>
@@ -5992,7 +6096,7 @@
                   <a:srgbClr val="1B2A2F"/>
                 </a:solidFill>
               </a:rPr>
-              <a:t>Holiday and working-day flags were inputs in both [1] and [3].</a:t>
+              <a:t>Both [1] and [3] used holiday and working-day indicators as inputs.</a:t>
             </a:r>
             <a:endParaRPr lang="en-US" sz="1400" dirty="0"/>
           </a:p>
@@ -6192,7 +6296,7 @@
                   <a:srgbClr val="0F3B3F"/>
                 </a:solidFill>
               </a:rPr>
-              <a:t>Tree ensembles: near-best accuracy, low cost</a:t>
+              <a:t>Tree ensembles: near-best accuracy at low cost</a:t>
             </a:r>
             <a:endParaRPr lang="en-US" sz="1400" dirty="0"/>
           </a:p>
@@ -6206,7 +6310,7 @@
                   <a:srgbClr val="1B2A2F"/>
                 </a:solidFill>
               </a:rPr>
-              <a:t>RF/XGBoost beat LR in [1], [2], [3], within ~0.3 pp MAPE of deep learning [3].</a:t>
+              <a:t>RF and XGBoost outperformed LR in [1]–[3], and came within 0.3 percentage points of deep learning's MAPE in [3].</a:t>
             </a:r>
             <a:endParaRPr lang="en-US" sz="1400" dirty="0"/>
           </a:p>
@@ -6420,7 +6524,7 @@
                   <a:srgbClr val="1B2A2F"/>
                 </a:solidFill>
               </a:rPr>
-              <a:t>Summer extremes and COVID-19 hurt [1]; 24 h multi-step is much harder [3].</a:t>
+              <a:t>Summer heat and COVID-19 reduced accuracy in [1]; 24-hour-ahead forecasts were much harder in [3].</a:t>
             </a:r>
             <a:endParaRPr lang="en-US" sz="1400" dirty="0"/>
           </a:p>
@@ -6508,7 +6612,7 @@
                   <a:schemeClr val="bg1"/>
                 </a:solidFill>
               </a:rPr>
-              <a:t>Errors by season and horizon; flag 2020 COVID period</a:t>
+              <a:t>Report errors by season and horizon; flag the 2020 COVID period</a:t>
             </a:r>
             <a:endParaRPr lang="en-US" sz="1300" dirty="0"/>
           </a:p>
@@ -6555,7 +6659,7 @@
                   <a:srgbClr val="1B2A2F"/>
                 </a:solidFill>
               </a:rPr>
-              <a:t>all four forecast a country, state or single home. None targets a city zone like Ottawa, or what solar, wind and EV fleets do to the net load left to serve.</a:t>
+              <a:t>the four studies forecast a whole country, a state or a single home. None targets a city zone such as Ottawa, or examines how solar, wind and EV fleets change the net load left to serve.</a:t>
             </a:r>
             <a:endParaRPr lang="en-US" sz="1300" dirty="0"/>
           </a:p>
@@ -6847,7 +6951,7 @@
                   <a:schemeClr val="tx1"/>
                 </a:solidFill>
               </a:rPr>
-              <a:t>IESO hourly demand (Ottawa zone), ECCC + Open-Meteo weather, Ontario holidays</a:t>
+              <a:t>IESO hourly demand (Ottawa zone), ECCC and Open-Meteo weather, Ontario holidays</a:t>
             </a:r>
             <a:endParaRPr lang="en-US" sz="1300" dirty="0"/>
           </a:p>
@@ -7506,7 +7610,7 @@
                   <a:schemeClr val="bg2"/>
                 </a:solidFill>
               </a:rPr>
-              <a:t>Solar and wind come from weather forecasts through physical models; EV charging from workday and holiday schedules. The result shows, hour by hour, how much dispatchable supply is needed and when flexible EV charging can be shifted.</a:t>
+              <a:t>Solar and wind output are estimated from weather data with physical models, and EV charging from workday and holiday schedules. The result shows, hour by hour, how much dispatchable supply is needed and when flexible EV charging can be shifted.</a:t>
             </a:r>
             <a:endParaRPr lang="en-US" sz="1800" dirty="0"/>
           </a:p>
@@ -9686,7 +9790,7 @@
                   <a:schemeClr val="tx2"/>
                 </a:solidFill>
               </a:rPr>
-              <a:t>Split: train 2020–2023 · validate 2024 · test 2025 (chronological, no shuffling, so no future data leaks into training).</a:t>
+              <a:t>Data split: training 2020–2023, validation 2024, test 2025. The split is chronological with no shuffling, so no future data leaks into training.</a:t>
             </a:r>
             <a:endParaRPr lang="en-US" sz="1400" dirty="0"/>
           </a:p>
@@ -9978,7 +10082,7 @@
                   <a:schemeClr val="tx1"/>
                 </a:solidFill>
               </a:rPr>
-              <a:t>10 MW AC fixed-tilt array near Ottawa. Output from real irradiance and temperature through pvlib; zero at night, low under winter snow.</a:t>
+              <a:t>A 10 MW (AC) fixed-tilt array near Ottawa. Output is modelled with pvlib from real irradiance and temperature: zero at night, reduced under snow.</a:t>
             </a:r>
             <a:endParaRPr lang="en-US" sz="1300" dirty="0"/>
           </a:p>
@@ -10126,7 +10230,7 @@
                   <a:schemeClr val="tx1"/>
                 </a:solidFill>
               </a:rPr>
-              <a:t>20 MW (e.g. 6 × 3.3 MW). Power curve: cut-in 3 m/s, rated 12 m/s, cut-out 25 m/s, from 100 m forecast wind speed.</a:t>
+              <a:t>A 20 MW farm (e.g., six 3.3 MW turbines). Power curve: cut-in 3 m/s, rated 12 m/s, cut-out 25 m/s, applied to 100 m wind speed.</a:t>
             </a:r>
             <a:endParaRPr lang="en-US" sz="1300" dirty="0"/>
           </a:p>
@@ -10274,7 +10378,7 @@
                   <a:schemeClr val="tx1"/>
                 </a:solidFill>
               </a:rPr>
-              <a:t>Follows temperature (heating and cooling degree-hours). Morning and evening peaks; higher on weekends and holidays.</a:t>
+              <a:t>Follows temperature (heating and cooling degree-hours), with morning and evening peaks; higher on weekends and holidays.</a:t>
             </a:r>
             <a:endParaRPr lang="en-US" sz="1300" dirty="0"/>
           </a:p>
@@ -10422,7 +10526,7 @@
                   <a:schemeClr val="tx1"/>
                 </a:solidFill>
               </a:rPr>
-              <a:t>Flat daytime block on workdays, reduced on weekends and statutory holidays, minimal overnight.</a:t>
+              <a:t>A flat daytime block on workdays, reduced on weekends and statutory holidays, and minimal overnight.</a:t>
             </a:r>
             <a:endParaRPr lang="en-US" sz="1300" dirty="0"/>
           </a:p>
@@ -10570,7 +10674,7 @@
                   <a:schemeClr val="tx1"/>
                 </a:solidFill>
               </a:rPr>
-              <a:t>300 fleet vehicles, ~60 kWh each per workday, charged overnight (22:00–06:00); ~30% of that on holidays.</a:t>
+              <a:t>300 fleet vehicles using about 60 kWh each per workday, charged overnight (22:00–06:00); about 30% of that on holidays.</a:t>
             </a:r>
             <a:endParaRPr lang="en-US" sz="1300" dirty="0"/>
           </a:p>
@@ -10718,7 +10822,7 @@
                   <a:schemeClr val="tx1"/>
                 </a:solidFill>
               </a:rPr>
-              <a:t>Shares are scaled so their sum matches the real IESO Ottawa-zone total. Every parameter is a variable we can stress-test.</a:t>
+              <a:t>Component shares are scaled so that they add up to the real IESO Ottawa-zone total. Every parameter can be varied for stress tests.</a:t>
             </a:r>
             <a:endParaRPr lang="en-US" sz="1300" dirty="0"/>
           </a:p>
@@ -10939,7 +11043,7 @@
                   <a:srgbClr val="1B2A2F"/>
                 </a:solidFill>
               </a:rPr>
-              <a:t>Floor every model must beat: demand(t+1) = demand(t), or same hour last week</a:t>
+              <a:t>The minimum bar for every model: demand(t+1) = demand(t), or the same hour last week</a:t>
             </a:r>
             <a:endParaRPr lang="en-US" sz="1500" dirty="0"/>
           </a:p>
@@ -11016,7 +11120,7 @@
                   <a:srgbClr val="1B2A2F"/>
                 </a:solidFill>
               </a:rPr>
-              <a:t>Interpretable baseline; shows how much is linear in temperature and calendar</a:t>
+              <a:t>An interpretable baseline that shows how much of the load is linear in temperature and calendar</a:t>
             </a:r>
             <a:endParaRPr lang="en-US" sz="1500" dirty="0"/>
           </a:p>
@@ -11093,7 +11197,7 @@
                   <a:srgbClr val="FFFFFF"/>
                 </a:solidFill>
               </a:rPr>
-              <a:t>Bagged trees [9]; captures the nonlinear (U-shaped) heating/cooling response</a:t>
+              <a:t>An ensemble of bagged trees [9] that captures the nonlinear (U-shaped) heating and cooling response</a:t>
             </a:r>
             <a:endParaRPr lang="en-US" sz="1500" dirty="0"/>
           </a:p>
@@ -11170,7 +11274,7 @@
                   <a:srgbClr val="FFFFFF"/>
                 </a:solidFill>
               </a:rPr>
-              <a:t>Gradient-boosted trees [10]; lowest RMSE of the three models in [1]</a:t>
+              <a:t>Gradient-boosted trees [10]; achieved the lowest RMSE of the three models in [1]</a:t>
             </a:r>
             <a:endParaRPr lang="en-US" sz="1500" dirty="0"/>
           </a:p>
@@ -11206,7 +11310,7 @@
                   <a:schemeClr val="tx2"/>
                 </a:solidFill>
               </a:rPr>
-              <a:t>Stretch goal: LSTM sequence model [4] if time allows.</a:t>
+              <a:t>Stretch goal: an LSTM sequence model [4], if time allows.</a:t>
             </a:r>
             <a:endParaRPr lang="en-US" sz="1300" dirty="0"/>
           </a:p>
@@ -11550,7 +11654,7 @@
                   <a:srgbClr val="1B2A2F"/>
                 </a:solidFill>
               </a:rPr>
-              <a:t>fit</a:t>
+              <a:t>goodness of fit</a:t>
             </a:r>
             <a:endParaRPr lang="en-US" sz="3000" dirty="0"/>
           </a:p>
@@ -11597,7 +11701,7 @@
                   <a:schemeClr val="tx1"/>
                 </a:solidFill>
               </a:rPr>
-              <a:t>errors by season, peak hours and holidays; feature importance; residual plots. Then net-load error after adding the solar, wind and EV scenarios.</a:t>
+              <a:t>errors by season, peak hours and holidays; feature importance; residual plots; and finally, net-load error once the solar, wind and EV scenarios are added.</a:t>
             </a:r>
             <a:endParaRPr lang="en-US" sz="1300" dirty="0"/>
           </a:p>
@@ -11825,7 +11929,7 @@
                   <a:srgbClr val="1B2A2F"/>
                 </a:solidFill>
               </a:rPr>
-              <a:t>Data is free, public and hourly: ~52,000 rows for 2020–2025, which trains in seconds to minutes on a laptop.</a:t>
+              <a:t>The data is free, public and hourly: about 52,000 rows for 2020–2025, small enough to train in seconds to minutes on a laptop.</a:t>
             </a:r>
             <a:endParaRPr lang="en-US" sz="1400" dirty="0"/>
           </a:p>
@@ -11843,7 +11947,7 @@
                   <a:srgbClr val="1B2A2F"/>
                 </a:solidFill>
               </a:rPr>
-              <a:t>Standard, well-documented libraries: pandas, scikit-learn, XGBoost, pvlib.</a:t>
+              <a:t>We use standard, well-documented libraries: pandas, scikit-learn, XGBoost and pvlib.</a:t>
             </a:r>
             <a:endParaRPr lang="en-US" sz="1400" dirty="0"/>
           </a:p>
@@ -11861,7 +11965,7 @@
                   <a:srgbClr val="1B2A2F"/>
                 </a:solidFill>
               </a:rPr>
-              <a:t>The core ML deliverable (steps 1–4) does not depend on the scenario layer, so the scenarios can't put it at risk.</a:t>
+              <a:t>The core ML deliverable (steps 1–4) does not depend on the scenario layer, so the scenarios cannot put it at risk.</a:t>
             </a:r>
             <a:endParaRPr lang="en-US" sz="1400" dirty="0"/>
           </a:p>
@@ -11879,7 +11983,7 @@
                   <a:srgbClr val="1B2A2F"/>
                 </a:solidFill>
               </a:rPr>
-              <a:t>Clear fallback: if zonal data is incomplete, we use IESO Ontario-wide hourly demand with the same pipeline.</a:t>
+              <a:t>Clear fallback: if the zonal data is incomplete, we will use IESO's Ontario-wide hourly demand with the same pipeline.</a:t>
             </a:r>
             <a:endParaRPr lang="en-US" sz="1400" dirty="0"/>
           </a:p>
@@ -11897,7 +12001,7 @@
                   <a:srgbClr val="1B2A2F"/>
                 </a:solidFill>
               </a:rPr>
-              <a:t>Out of scope: real-time control, grid power-flow simulation, private utility data.</a:t>
+              <a:t>Out of scope: real-time control, power-flow simulation of the grid, and private utility data.</a:t>
             </a:r>
             <a:endParaRPr lang="en-US" sz="1400" dirty="0"/>
           </a:p>
@@ -12070,7 +12174,7 @@
                   <a:srgbClr val="1B2A2F"/>
                 </a:solidFill>
               </a:rPr>
-              <a:t>Collect and clean data; feature pipeline; EDA</a:t>
+              <a:t>Collect and clean data; build features; explore the data</a:t>
             </a:r>
             <a:endParaRPr lang="en-US" sz="1400" dirty="0"/>
           </a:p>
@@ -12145,7 +12249,7 @@
                   <a:srgbClr val="1B2A2F"/>
                 </a:solidFill>
               </a:rPr>
-              <a:t>Train baselines, RF and XGBoost; tune on 2024</a:t>
+              <a:t>Train the baselines, RF and XGBoost; tune on 2024 data</a:t>
             </a:r>
             <a:endParaRPr lang="en-US" sz="1400" dirty="0"/>
           </a:p>
@@ -12220,7 +12324,7 @@
                   <a:srgbClr val="1B2A2F"/>
                 </a:solidFill>
               </a:rPr>
-              <a:t>Scenario layer: solar, wind, EV, net load</a:t>
+              <a:t>Build the scenario layer: solar, wind, EV and net load</a:t>
             </a:r>
             <a:endParaRPr lang="en-US" sz="1400" dirty="0"/>
           </a:p>
@@ -12295,7 +12399,7 @@
                   <a:srgbClr val="1B2A2F"/>
                 </a:solidFill>
               </a:rPr>
-              <a:t>Test-year analysis; final presentation</a:t>
+              <a:t>Analyse the test year; prepare the final presentation</a:t>
             </a:r>
             <a:endParaRPr lang="en-US" sz="1400" dirty="0"/>
           </a:p>
@@ -12370,7 +12474,7 @@
                   <a:srgbClr val="1B2A2F"/>
                 </a:solidFill>
               </a:rPr>
-              <a:t>IEEE-format final report</a:t>
+              <a:t>Submit the final report in IEEE format</a:t>
             </a:r>
             <a:endParaRPr lang="en-US" sz="1400" dirty="0"/>
           </a:p>

</xml_diff>

<commit_message>
Explain the scenario layer in depth in the study notes
Add Part 5A to STUDY_NOTES.md: the net-load equation term by term,
how solar, wind and EV load are calculated, the difference between
scenario additions and load decomposition, a worked three-hour
example, outputs, accuracy, limitations and likely questions. Extend
the slide 5 speaker notes to match and add a script that regenerates
the plain-text phone notes.

Co-Authored-By: Claude Opus 5.5 <noreply@anthropic.com>
Claude-Session: https://claude.ai/code/session_01UdtV5L4ADJ2YS9drm8okZJ
</commit_message>
<xml_diff>
--- a/presentation/ELG5255_Phase1_Ottawa_Load_Forecasting.pptx
+++ b/presentation/ELG5255_Phase1_Ottawa_Load_Forecasting.pptx
@@ -118,19 +118,19 @@
   <p:extLst>
     <p:ext uri="{521415D9-36F7-43E2-AB2F-B90AF26B5E84}">
       <p14:sectionLst xmlns:p14="http://schemas.microsoft.com/office/powerpoint/2010/main">
-        <p14:section name="Introduction" id="{6a5dd4e8-011c-8696-00a3-a002bda99432}">
+        <p14:section name="Introduction" id="{a654f163-77a2-6fe9-4ef9-688093511fd6}">
           <p14:sldIdLst>
             <p14:sldId id="256"/>
             <p14:sldId id="257"/>
           </p14:sldIdLst>
         </p14:section>
-        <p14:section name="State of the art" id="{5df3b3a8-2b26-4e3e-2f0a-846d6c335ddf}">
+        <p14:section name="State of the art" id="{2e3fe88c-89ec-a429-7223-8d6e10d09adb}">
           <p14:sldIdLst>
             <p14:sldId id="258"/>
             <p14:sldId id="259"/>
           </p14:sldIdLst>
         </p14:section>
-        <p14:section name="Proposal" id="{b365a31b-9fc5-740b-13a6-cecdd1890216}">
+        <p14:section name="Proposal" id="{55068c63-e603-027d-8ad5-415855c9005f}">
           <p14:sldIdLst>
             <p14:sldId id="260"/>
             <p14:sldId id="261"/>
@@ -138,7 +138,7 @@
             <p14:sldId id="263"/>
           </p14:sldIdLst>
         </p14:section>
-        <p14:section name="Plan" id="{2c756542-2863-e649-ad44-8d26ddc7ae1a}">
+        <p14:section name="Plan" id="{911b7754-7d01-9f16-e175-c6280fdc9259}">
           <p14:sldIdLst>
             <p14:sldId id="264"/>
             <p14:sldId id="265"/>
@@ -1584,7 +1584,12 @@
 - HDD/CDD (here degree-hours) = how far the temperature is below or above a base of about 18 °C; this captures heating and cooling demand.
 IF ASKED
 - Is step 5 machine learning? Not in itself: it is a physics- and rule-based simulation driven by our ML forecast. It turns the forecast into a smart-grid decision tool. The graded ML is in steps 1–4.
-- Is this real-time? No. We use historical data to show how the system would work; real-time control is out of scope.</a:t>
+- Is this real-time? No. We replay historical hours one by one to show how the system would work; real-time control is out of scope.
+- Why is EV charging added, not subtracted? The fleet is a new load that is not in today's data, so it increases what the grid must supply.
+- Aren't 10 MW and 20 MW tiny? Yes, only a few percent of the zone's load at most. They are a base case; every size is a parameter we can scale up.
+- Why doesn't solar help the winter peak? Ottawa's winter peak comes after sunset, when solar output is zero.
+- What does 'dynamic load distribution' mean? Splitting the forecast into residential, industrial/commercial and EV shares each hour, and moving flexible EV charging to the night-time valley (valley filling).
+- Full explanation with formulas and a worked example: STUDY_NOTES.md, Part 5A.</a:t>
             </a:r>
             <a:endParaRPr lang="en-US" dirty="0"/>
           </a:p>

</xml_diff>